<commit_message>
Use supplied photo cards: split collage into 8 tiles and place photos in slides
Co-Authored-By: Claude Sonnet 5.5 <noreply@anthropic.com>
Claude-Session: https://claude.ai/code/session_01N5vJU63TyzQVMvnBd9vT9r
</commit_message>
<xml_diff>
--- a/shokr_tavakkol/shokr_va_tavakkol.pptx
+++ b/shokr_tavakkol/shokr_va_tavakkol.pptx
@@ -131,14 +131,14 @@
   <p:extLst>
     <p:ext uri="{521415D9-36F7-43E2-AB2F-B90AF26B5E84}">
       <p14:sectionLst xmlns:p14="http://schemas.microsoft.com/office/powerpoint/2010/main">
-        <p14:section name="مقدمه" id="{4ea2dabe-f26c-2b80-a6a8-bd234f4c2e57}">
+        <p14:section name="مقدمه" id="{21eaa44b-321c-821c-b7da-79e17c6d7a5a}">
           <p14:sldIdLst>
             <p14:sldId id="256"/>
             <p14:sldId id="257"/>
             <p14:sldId id="258"/>
           </p14:sldIdLst>
         </p14:section>
-        <p14:section name="شکر" id="{0d5d4281-303a-9b6c-6ab5-049bac660f07}">
+        <p14:section name="شکر" id="{5a2e6010-438b-c21d-39ca-29027c6cf4c5}">
           <p14:sldIdLst>
             <p14:sldId id="259"/>
             <p14:sldId id="260"/>
@@ -152,7 +152,7 @@
             <p14:sldId id="268"/>
           </p14:sldIdLst>
         </p14:section>
-        <p14:section name="توکل" id="{66da02c0-1fa1-2770-44b2-454c672c6138}">
+        <p14:section name="توکل" id="{6c0e9325-4ace-e9f7-75db-c589c67ce170}">
           <p14:sldIdLst>
             <p14:sldId id="269"/>
             <p14:sldId id="270"/>
@@ -164,7 +164,7 @@
             <p14:sldId id="276"/>
           </p14:sldIdLst>
         </p14:section>
-        <p14:section name="جمع‌بندی" id="{08d088bd-85d4-a963-b838-9bf8885886cc}">
+        <p14:section name="جمع‌بندی" id="{887b2a10-1304-c2c5-e33d-47bb9f2437be}">
           <p14:sldIdLst>
             <p14:sldId id="277"/>
             <p14:sldId id="278"/>
@@ -3375,53 +3375,23 @@
         </p:nvSpPr>
         <p:spPr>
           <a:xfrm>
-            <a:off x="0" y="0"/>
-            <a:ext cx="5120640" cy="6858000"/>
-          </a:xfrm>
-          <a:prstGeom prst="rect">
-            <a:avLst/>
-          </a:prstGeom>
-          <a:solidFill>
-            <a:srgbClr val="0B5048"/>
-          </a:solidFill>
-          <a:ln w="12700">
+            <a:off x="694944" y="969264"/>
+            <a:ext cx="4480560" cy="5212080"/>
+          </a:xfrm>
+          <a:prstGeom prst="rect">
+            <a:avLst/>
+          </a:prstGeom>
+          <a:ln w="19050">
             <a:solidFill>
-              <a:srgbClr val="0B5048"/>
+              <a:schemeClr val="accent1"/>
             </a:solidFill>
             <a:prstDash val="solid"/>
           </a:ln>
         </p:spPr>
       </p:sp>
-      <p:sp>
-        <p:nvSpPr>
-          <p:cNvPr id="3" name="Shape 1"/>
-          <p:cNvSpPr/>
-          <p:nvPr/>
-        </p:nvSpPr>
-        <p:spPr>
-          <a:xfrm>
-            <a:off x="819302" y="1687982"/>
-            <a:ext cx="3482035" cy="3482035"/>
-          </a:xfrm>
-          <a:prstGeom prst="ellipse">
-            <a:avLst/>
-          </a:prstGeom>
-          <a:solidFill>
-            <a:srgbClr val="8CC1B2">
-              <a:alpha val="18000"/>
-            </a:srgbClr>
-          </a:solidFill>
-          <a:ln w="12700">
-            <a:solidFill>
-              <a:srgbClr val="8CC1B2"/>
-            </a:solidFill>
-            <a:prstDash val="solid"/>
-          </a:ln>
-        </p:spPr>
-      </p:sp>
       <p:pic>
         <p:nvPicPr>
-          <p:cNvPr id="4" name="icon FaMosque" descr="preencoded.png">    </p:cNvPr>
+          <p:cNvPr id="3" name="Image 0" descr="title">    </p:cNvPr>
           <p:cNvPicPr>
             <a:picLocks noChangeAspect="1"/>
           </p:cNvPicPr>
@@ -3435,8 +3405,8 @@
         </p:blipFill>
         <p:spPr>
           <a:xfrm>
-            <a:off x="1741018" y="2609698"/>
-            <a:ext cx="1638605" cy="1638605"/>
+            <a:off x="548640" y="822960"/>
+            <a:ext cx="4480560" cy="5212080"/>
           </a:xfrm>
           <a:prstGeom prst="rect">
             <a:avLst/>
@@ -3445,7 +3415,7 @@
       </p:pic>
       <p:sp>
         <p:nvSpPr>
-          <p:cNvPr id="5" name="Text 2"/>
+          <p:cNvPr id="4" name="Text 1"/>
           <p:cNvSpPr txBox="1"/>
           <p:nvPr/>
         </p:nvSpPr>
@@ -3481,7 +3451,7 @@
       </p:sp>
       <p:sp>
         <p:nvSpPr>
-          <p:cNvPr id="6" name="Text 3"/>
+          <p:cNvPr id="5" name="Text 2"/>
           <p:cNvSpPr txBox="1"/>
           <p:nvPr/>
         </p:nvSpPr>
@@ -3517,7 +3487,7 @@
       </p:sp>
       <p:sp>
         <p:nvSpPr>
-          <p:cNvPr id="7" name="Text 4"/>
+          <p:cNvPr id="6" name="Text 3"/>
           <p:cNvSpPr txBox="1"/>
           <p:nvPr/>
         </p:nvSpPr>
@@ -3553,7 +3523,7 @@
       </p:sp>
       <p:sp>
         <p:nvSpPr>
-          <p:cNvPr id="8" name="Text 5"/>
+          <p:cNvPr id="7" name="Text 4"/>
           <p:cNvSpPr txBox="1"/>
           <p:nvPr/>
         </p:nvSpPr>
@@ -3589,7 +3559,7 @@
       </p:sp>
       <p:sp>
         <p:nvSpPr>
-          <p:cNvPr id="9" name="Text 6"/>
+          <p:cNvPr id="8" name="Text 5"/>
           <p:cNvSpPr txBox="1"/>
           <p:nvPr/>
         </p:nvSpPr>
@@ -6767,53 +6737,23 @@
         </p:nvSpPr>
         <p:spPr>
           <a:xfrm>
-            <a:off x="0" y="0"/>
-            <a:ext cx="4937760" cy="6858000"/>
-          </a:xfrm>
-          <a:prstGeom prst="rect">
-            <a:avLst/>
-          </a:prstGeom>
-          <a:solidFill>
-            <a:srgbClr val="0B5048"/>
-          </a:solidFill>
-          <a:ln w="12700">
+            <a:off x="694944" y="1517904"/>
+            <a:ext cx="4389120" cy="4572000"/>
+          </a:xfrm>
+          <a:prstGeom prst="rect">
+            <a:avLst/>
+          </a:prstGeom>
+          <a:ln w="19050">
             <a:solidFill>
-              <a:srgbClr val="0B5048"/>
+              <a:schemeClr val="accent1"/>
             </a:solidFill>
             <a:prstDash val="solid"/>
           </a:ln>
         </p:spPr>
       </p:sp>
-      <p:sp>
-        <p:nvSpPr>
-          <p:cNvPr id="3" name="Shape 1"/>
-          <p:cNvSpPr/>
-          <p:nvPr/>
-        </p:nvSpPr>
-        <p:spPr>
-          <a:xfrm>
-            <a:off x="790042" y="1750162"/>
-            <a:ext cx="3357677" cy="3357677"/>
-          </a:xfrm>
-          <a:prstGeom prst="ellipse">
-            <a:avLst/>
-          </a:prstGeom>
-          <a:solidFill>
-            <a:srgbClr val="8CC1B2">
-              <a:alpha val="18000"/>
-            </a:srgbClr>
-          </a:solidFill>
-          <a:ln w="12700">
-            <a:solidFill>
-              <a:srgbClr val="8CC1B2"/>
-            </a:solidFill>
-            <a:prstDash val="solid"/>
-          </a:ln>
-        </p:spPr>
-      </p:sp>
       <p:pic>
         <p:nvPicPr>
-          <p:cNvPr id="4" name="icon FaMountain" descr="preencoded.png">    </p:cNvPr>
+          <p:cNvPr id="3" name="Image 0" descr="tav_div">    </p:cNvPr>
           <p:cNvPicPr>
             <a:picLocks noChangeAspect="1"/>
           </p:cNvPicPr>
@@ -6827,8 +6767,8 @@
         </p:blipFill>
         <p:spPr>
           <a:xfrm>
-            <a:off x="1678838" y="2638958"/>
-            <a:ext cx="1580083" cy="1580083"/>
+            <a:off x="548640" y="1371600"/>
+            <a:ext cx="4389120" cy="4572000"/>
           </a:xfrm>
           <a:prstGeom prst="rect">
             <a:avLst/>
@@ -6837,7 +6777,7 @@
       </p:pic>
       <p:sp>
         <p:nvSpPr>
-          <p:cNvPr id="5" name="Text 2"/>
+          <p:cNvPr id="4" name="Text 1"/>
           <p:cNvSpPr txBox="1"/>
           <p:nvPr/>
         </p:nvSpPr>
@@ -6873,7 +6813,7 @@
       </p:sp>
       <p:sp>
         <p:nvSpPr>
-          <p:cNvPr id="6" name="Text 3"/>
+          <p:cNvPr id="5" name="Text 2"/>
           <p:cNvSpPr txBox="1"/>
           <p:nvPr/>
         </p:nvSpPr>
@@ -6909,7 +6849,7 @@
       </p:sp>
       <p:sp>
         <p:nvSpPr>
-          <p:cNvPr id="7" name="Text 4"/>
+          <p:cNvPr id="6" name="Text 3"/>
           <p:cNvSpPr txBox="1"/>
           <p:nvPr/>
         </p:nvSpPr>
@@ -6945,7 +6885,7 @@
       </p:sp>
       <p:sp>
         <p:nvSpPr>
-          <p:cNvPr id="8" name="Text 5"/>
+          <p:cNvPr id="7" name="Text 4"/>
           <p:cNvSpPr txBox="1"/>
           <p:nvPr/>
         </p:nvSpPr>
@@ -6984,7 +6924,7 @@
       </p:sp>
       <p:sp>
         <p:nvSpPr>
-          <p:cNvPr id="9" name="Text 6"/>
+          <p:cNvPr id="8" name="Text 5"/>
           <p:cNvSpPr txBox="1"/>
           <p:nvPr/>
         </p:nvSpPr>
@@ -7081,19 +7021,45 @@
           </a:p>
         </p:txBody>
       </p:sp>
-      <p:sp>
-        <p:nvSpPr>
-          <p:cNvPr id="3" name="Shape 1"/>
+      <p:pic>
+        <p:nvPicPr>
+          <p:cNvPr id="3" name="Image 0" descr="tav_def">    </p:cNvPr>
+          <p:cNvPicPr>
+            <a:picLocks noChangeAspect="1"/>
+          </p:cNvPicPr>
+          <p:nvPr/>
+        </p:nvPicPr>
+        <p:blipFill>
+          <a:blip r:embed="rId1"/>
+          <a:stretch>
+            <a:fillRect/>
+          </a:stretch>
+        </p:blipFill>
+        <p:spPr>
+          <a:xfrm>
+            <a:off x="7619695" y="1463040"/>
+            <a:ext cx="4023360" cy="2926080"/>
+          </a:xfrm>
+          <a:prstGeom prst="rect">
+            <a:avLst/>
+          </a:prstGeom>
+        </p:spPr>
+      </p:pic>
+      <p:sp>
+        <p:nvSpPr>
+          <p:cNvPr id="4" name="Shape 1"/>
           <p:cNvSpPr/>
           <p:nvPr/>
         </p:nvSpPr>
         <p:spPr>
           <a:xfrm>
-            <a:off x="7619695" y="1463040"/>
-            <a:ext cx="4023360" cy="4572000"/>
-          </a:xfrm>
-          <a:prstGeom prst="rect">
-            <a:avLst/>
+            <a:off x="7619695" y="4572000"/>
+            <a:ext cx="4023360" cy="1463040"/>
+          </a:xfrm>
+          <a:prstGeom prst="roundRect">
+            <a:avLst>
+              <a:gd name="adj" fmla="val 8750"/>
+            </a:avLst>
           </a:prstGeom>
           <a:solidFill>
             <a:srgbClr val="0B5048"/>
@@ -7108,55 +7074,40 @@
       </p:sp>
       <p:sp>
         <p:nvSpPr>
-          <p:cNvPr id="4" name="Shape 2"/>
-          <p:cNvSpPr/>
-          <p:nvPr/>
-        </p:nvSpPr>
-        <p:spPr>
-          <a:xfrm>
-            <a:off x="8263433" y="2381098"/>
-            <a:ext cx="2735885" cy="2735885"/>
-          </a:xfrm>
-          <a:prstGeom prst="ellipse">
-            <a:avLst/>
-          </a:prstGeom>
-          <a:solidFill>
-            <a:srgbClr val="8CC1B2">
-              <a:alpha val="18000"/>
-            </a:srgbClr>
-          </a:solidFill>
-          <a:ln w="12700">
-            <a:solidFill>
-              <a:srgbClr val="8CC1B2"/>
-            </a:solidFill>
-            <a:prstDash val="solid"/>
-          </a:ln>
-        </p:spPr>
-      </p:sp>
-      <p:pic>
-        <p:nvPicPr>
-          <p:cNvPr id="5" name="icon FaRoute" descr="preencoded.png">    </p:cNvPr>
-          <p:cNvPicPr>
-            <a:picLocks noChangeAspect="1"/>
-          </p:cNvPicPr>
-          <p:nvPr/>
-        </p:nvPicPr>
-        <p:blipFill>
-          <a:blip r:embed="rId1"/>
-          <a:stretch>
-            <a:fillRect/>
-          </a:stretch>
-        </p:blipFill>
-        <p:spPr>
-          <a:xfrm>
-            <a:off x="8987638" y="3105302"/>
-            <a:ext cx="1287475" cy="1287475"/>
-          </a:xfrm>
-          <a:prstGeom prst="rect">
-            <a:avLst/>
-          </a:prstGeom>
-        </p:spPr>
-      </p:pic>
+          <p:cNvPr id="5" name="Text 2"/>
+          <p:cNvSpPr txBox="1"/>
+          <p:nvPr/>
+        </p:nvSpPr>
+        <p:spPr>
+          <a:xfrm>
+            <a:off x="7894015" y="4572000"/>
+            <a:ext cx="3474720" cy="1463040"/>
+          </a:xfrm>
+          <a:prstGeom prst="rect">
+            <a:avLst/>
+          </a:prstGeom>
+          <a:noFill/>
+          <a:ln/>
+        </p:spPr>
+        <p:txBody>
+          <a:bodyPr wrap="square" lIns="0" tIns="0" rIns="0" bIns="0" rtlCol="0" anchor="ctr"/>
+          <a:lstStyle/>
+          <a:p>
+            <a:pPr rtl="1" algn="r" indent="0" marL="0">
+              <a:buNone/>
+            </a:pPr>
+            <a:r>
+              <a:rPr lang="fa-IR" altLang="en-US" sz="1800" b="1" dirty="0">
+                <a:solidFill>
+                  <a:schemeClr val="bg1"/>
+                </a:solidFill>
+              </a:rPr>
+              <a:t>انسان با تمام قدرت تلاش می‌کند، اما نتیجه را به خدا می‌سپارد.</a:t>
+            </a:r>
+            <a:endParaRPr lang="fa-IR" sz="1800" dirty="0"/>
+          </a:p>
+        </p:txBody>
+      </p:sp>
       <p:sp>
         <p:nvSpPr>
           <p:cNvPr id="6" name="Shape 3"/>
@@ -12621,61 +12572,9 @@
           </a:ln>
         </p:spPr>
       </p:sp>
-      <p:sp>
-        <p:nvSpPr>
-          <p:cNvPr id="4" name="Shape 2"/>
-          <p:cNvSpPr/>
-          <p:nvPr/>
-        </p:nvSpPr>
-        <p:spPr>
-          <a:xfrm>
-            <a:off x="8158277" y="1508760"/>
-            <a:ext cx="3484778" cy="1554480"/>
-          </a:xfrm>
-          <a:prstGeom prst="rect">
-            <a:avLst/>
-          </a:prstGeom>
-          <a:solidFill>
-            <a:srgbClr val="0B5048"/>
-          </a:solidFill>
-          <a:ln w="12700">
-            <a:solidFill>
-              <a:srgbClr val="0B5048"/>
-            </a:solidFill>
-            <a:prstDash val="solid"/>
-          </a:ln>
-        </p:spPr>
-      </p:sp>
-      <p:sp>
-        <p:nvSpPr>
-          <p:cNvPr id="5" name="Shape 3"/>
-          <p:cNvSpPr/>
-          <p:nvPr/>
-        </p:nvSpPr>
-        <p:spPr>
-          <a:xfrm>
-            <a:off x="9372143" y="1757477"/>
-            <a:ext cx="1057046" cy="1057046"/>
-          </a:xfrm>
-          <a:prstGeom prst="ellipse">
-            <a:avLst/>
-          </a:prstGeom>
-          <a:solidFill>
-            <a:srgbClr val="8CC1B2">
-              <a:alpha val="18000"/>
-            </a:srgbClr>
-          </a:solidFill>
-          <a:ln w="12700">
-            <a:solidFill>
-              <a:srgbClr val="8CC1B2"/>
-            </a:solidFill>
-            <a:prstDash val="solid"/>
-          </a:ln>
-        </p:spPr>
-      </p:sp>
       <p:pic>
         <p:nvPicPr>
-          <p:cNvPr id="6" name="icon FaSun" descr="preencoded.png">    </p:cNvPr>
+          <p:cNvPr id="4" name="Image 0" descr="day_morning">    </p:cNvPr>
           <p:cNvPicPr>
             <a:picLocks noChangeAspect="1"/>
           </p:cNvPicPr>
@@ -12689,8 +12588,8 @@
         </p:blipFill>
         <p:spPr>
           <a:xfrm>
-            <a:off x="9651949" y="2037283"/>
-            <a:ext cx="497434" cy="497434"/>
+            <a:off x="8158277" y="1508760"/>
+            <a:ext cx="3484778" cy="1554480"/>
           </a:xfrm>
           <a:prstGeom prst="rect">
             <a:avLst/>
@@ -12699,7 +12598,7 @@
       </p:pic>
       <p:sp>
         <p:nvSpPr>
-          <p:cNvPr id="7" name="Text 4"/>
+          <p:cNvPr id="5" name="Text 2"/>
           <p:cNvSpPr txBox="1"/>
           <p:nvPr/>
         </p:nvSpPr>
@@ -12735,7 +12634,7 @@
       </p:sp>
       <p:sp>
         <p:nvSpPr>
-          <p:cNvPr id="8" name="Text 5"/>
+          <p:cNvPr id="6" name="Text 3"/>
           <p:cNvSpPr txBox="1"/>
           <p:nvPr/>
         </p:nvSpPr>
@@ -12811,7 +12710,7 @@
       </p:sp>
       <p:sp>
         <p:nvSpPr>
-          <p:cNvPr id="9" name="Shape 6"/>
+          <p:cNvPr id="7" name="Shape 4"/>
           <p:cNvSpPr/>
           <p:nvPr/>
         </p:nvSpPr>
@@ -12838,7 +12737,7 @@
       </p:sp>
       <p:sp>
         <p:nvSpPr>
-          <p:cNvPr id="10" name="Shape 7"/>
+          <p:cNvPr id="8" name="Shape 5"/>
           <p:cNvSpPr/>
           <p:nvPr/>
         </p:nvSpPr>
@@ -12863,7 +12762,7 @@
       </p:sp>
       <p:sp>
         <p:nvSpPr>
-          <p:cNvPr id="11" name="Shape 8"/>
+          <p:cNvPr id="9" name="Shape 6"/>
           <p:cNvSpPr/>
           <p:nvPr/>
         </p:nvSpPr>
@@ -12890,7 +12789,7 @@
       </p:sp>
       <p:pic>
         <p:nvPicPr>
-          <p:cNvPr id="12" name="icon FaBriefcase" descr="preencoded.png">    </p:cNvPr>
+          <p:cNvPr id="10" name="icon FaBriefcase" descr="preencoded.png">    </p:cNvPr>
           <p:cNvPicPr>
             <a:picLocks noChangeAspect="1"/>
           </p:cNvPicPr>
@@ -12914,7 +12813,7 @@
       </p:pic>
       <p:sp>
         <p:nvSpPr>
-          <p:cNvPr id="13" name="Text 9"/>
+          <p:cNvPr id="11" name="Text 7"/>
           <p:cNvSpPr txBox="1"/>
           <p:nvPr/>
         </p:nvSpPr>
@@ -12950,7 +12849,7 @@
       </p:sp>
       <p:sp>
         <p:nvSpPr>
-          <p:cNvPr id="14" name="Text 10"/>
+          <p:cNvPr id="12" name="Text 8"/>
           <p:cNvSpPr txBox="1"/>
           <p:nvPr/>
         </p:nvSpPr>
@@ -13026,7 +12925,7 @@
       </p:sp>
       <p:sp>
         <p:nvSpPr>
-          <p:cNvPr id="15" name="Shape 11"/>
+          <p:cNvPr id="13" name="Shape 9"/>
           <p:cNvSpPr/>
           <p:nvPr/>
         </p:nvSpPr>
@@ -13051,61 +12950,9 @@
           </a:ln>
         </p:spPr>
       </p:sp>
-      <p:sp>
-        <p:nvSpPr>
-          <p:cNvPr id="16" name="Shape 12"/>
-          <p:cNvSpPr/>
-          <p:nvPr/>
-        </p:nvSpPr>
-        <p:spPr>
-          <a:xfrm>
-            <a:off x="548640" y="1508760"/>
-            <a:ext cx="3484778" cy="1554480"/>
-          </a:xfrm>
-          <a:prstGeom prst="rect">
-            <a:avLst/>
-          </a:prstGeom>
-          <a:solidFill>
-            <a:srgbClr val="0B5048"/>
-          </a:solidFill>
-          <a:ln w="12700">
-            <a:solidFill>
-              <a:srgbClr val="0B5048"/>
-            </a:solidFill>
-            <a:prstDash val="solid"/>
-          </a:ln>
-        </p:spPr>
-      </p:sp>
-      <p:sp>
-        <p:nvSpPr>
-          <p:cNvPr id="17" name="Shape 13"/>
-          <p:cNvSpPr/>
-          <p:nvPr/>
-        </p:nvSpPr>
-        <p:spPr>
-          <a:xfrm>
-            <a:off x="1762506" y="1757477"/>
-            <a:ext cx="1057046" cy="1057046"/>
-          </a:xfrm>
-          <a:prstGeom prst="ellipse">
-            <a:avLst/>
-          </a:prstGeom>
-          <a:solidFill>
-            <a:srgbClr val="8CC1B2">
-              <a:alpha val="18000"/>
-            </a:srgbClr>
-          </a:solidFill>
-          <a:ln w="12700">
-            <a:solidFill>
-              <a:srgbClr val="8CC1B2"/>
-            </a:solidFill>
-            <a:prstDash val="solid"/>
-          </a:ln>
-        </p:spPr>
-      </p:sp>
       <p:pic>
         <p:nvPicPr>
-          <p:cNvPr id="18" name="icon FaMoon" descr="preencoded.png">    </p:cNvPr>
+          <p:cNvPr id="14" name="Image 2" descr="day_night">    </p:cNvPr>
           <p:cNvPicPr>
             <a:picLocks noChangeAspect="1"/>
           </p:cNvPicPr>
@@ -13119,8 +12966,8 @@
         </p:blipFill>
         <p:spPr>
           <a:xfrm>
-            <a:off x="2042312" y="2037283"/>
-            <a:ext cx="497434" cy="497434"/>
+            <a:off x="548640" y="1508760"/>
+            <a:ext cx="3484778" cy="1554480"/>
           </a:xfrm>
           <a:prstGeom prst="rect">
             <a:avLst/>
@@ -13129,7 +12976,7 @@
       </p:pic>
       <p:sp>
         <p:nvSpPr>
-          <p:cNvPr id="19" name="Text 14"/>
+          <p:cNvPr id="15" name="Text 10"/>
           <p:cNvSpPr txBox="1"/>
           <p:nvPr/>
         </p:nvSpPr>
@@ -13165,7 +13012,7 @@
       </p:sp>
       <p:sp>
         <p:nvSpPr>
-          <p:cNvPr id="20" name="Text 15"/>
+          <p:cNvPr id="16" name="Text 11"/>
           <p:cNvSpPr txBox="1"/>
           <p:nvPr/>
         </p:nvSpPr>
@@ -14307,18 +14154,42 @@
           </a:ln>
         </p:spPr>
       </p:sp>
-      <p:sp>
-        <p:nvSpPr>
-          <p:cNvPr id="4" name="Shape 2"/>
-          <p:cNvSpPr/>
-          <p:nvPr/>
-        </p:nvSpPr>
+      <p:pic>
+        <p:nvPicPr>
+          <p:cNvPr id="4" name="Image 0" descr="intro">    </p:cNvPr>
+          <p:cNvPicPr>
+            <a:picLocks noChangeAspect="1"/>
+          </p:cNvPicPr>
+          <p:nvPr/>
+        </p:nvPicPr>
+        <p:blipFill>
+          <a:blip r:embed="rId1"/>
+          <a:stretch>
+            <a:fillRect/>
+          </a:stretch>
+        </p:blipFill>
         <p:spPr>
           <a:xfrm>
             <a:off x="548640" y="1463040"/>
             <a:ext cx="4206240" cy="4572000"/>
           </a:xfrm>
           <a:prstGeom prst="rect">
+            <a:avLst/>
+          </a:prstGeom>
+        </p:spPr>
+      </p:pic>
+      <p:sp>
+        <p:nvSpPr>
+          <p:cNvPr id="5" name="Shape 2"/>
+          <p:cNvSpPr/>
+          <p:nvPr/>
+        </p:nvSpPr>
+        <p:spPr>
+          <a:xfrm>
+            <a:off x="10774375" y="1645920"/>
+            <a:ext cx="868680" cy="868680"/>
+          </a:xfrm>
+          <a:prstGeom prst="ellipse">
             <a:avLst/>
           </a:prstGeom>
           <a:solidFill>
@@ -14332,51 +14203,24 @@
           </a:ln>
         </p:spPr>
       </p:sp>
-      <p:sp>
-        <p:nvSpPr>
-          <p:cNvPr id="5" name="Shape 3"/>
-          <p:cNvSpPr/>
-          <p:nvPr/>
-        </p:nvSpPr>
-        <p:spPr>
-          <a:xfrm>
-            <a:off x="1221638" y="2318918"/>
-            <a:ext cx="2860243" cy="2860243"/>
-          </a:xfrm>
-          <a:prstGeom prst="ellipse">
-            <a:avLst/>
-          </a:prstGeom>
-          <a:solidFill>
-            <a:srgbClr val="8CC1B2">
-              <a:alpha val="18000"/>
-            </a:srgbClr>
-          </a:solidFill>
-          <a:ln w="12700">
-            <a:solidFill>
-              <a:srgbClr val="8CC1B2"/>
-            </a:solidFill>
-            <a:prstDash val="solid"/>
-          </a:ln>
-        </p:spPr>
-      </p:sp>
       <p:pic>
         <p:nvPicPr>
-          <p:cNvPr id="6" name="icon FaSun" descr="preencoded.png">    </p:cNvPr>
+          <p:cNvPr id="6" name="icon FaQuran" descr="preencoded.png">    </p:cNvPr>
           <p:cNvPicPr>
             <a:picLocks noChangeAspect="1"/>
           </p:cNvPicPr>
           <p:nvPr/>
         </p:nvPicPr>
         <p:blipFill>
-          <a:blip r:embed="rId1"/>
+          <a:blip r:embed="rId2"/>
           <a:stretch>
             <a:fillRect/>
           </a:stretch>
         </p:blipFill>
         <p:spPr>
           <a:xfrm>
-            <a:off x="1978762" y="3076042"/>
-            <a:ext cx="1345997" cy="1345997"/>
+            <a:off x="11008919" y="1880464"/>
+            <a:ext cx="399593" cy="399593"/>
           </a:xfrm>
           <a:prstGeom prst="rect">
             <a:avLst/>
@@ -14385,13 +14229,85 @@
       </p:pic>
       <p:sp>
         <p:nvSpPr>
-          <p:cNvPr id="7" name="Shape 4"/>
+          <p:cNvPr id="7" name="Text 3"/>
+          <p:cNvSpPr txBox="1"/>
+          <p:nvPr/>
+        </p:nvSpPr>
+        <p:spPr>
+          <a:xfrm>
+            <a:off x="5394960" y="1463040"/>
+            <a:ext cx="5105095" cy="457200"/>
+          </a:xfrm>
+          <a:prstGeom prst="rect">
+            <a:avLst/>
+          </a:prstGeom>
+          <a:noFill/>
+          <a:ln/>
+        </p:spPr>
+        <p:txBody>
+          <a:bodyPr wrap="square" lIns="0" tIns="0" rIns="0" bIns="0" rtlCol="0" anchor="t"/>
+          <a:lstStyle/>
+          <a:p>
+            <a:pPr rtl="1" algn="r" indent="0" marL="0">
+              <a:buNone/>
+            </a:pPr>
+            <a:r>
+              <a:rPr lang="fa-IR" altLang="en-US" sz="2200" b="1" dirty="0">
+                <a:solidFill>
+                  <a:schemeClr val="tx2"/>
+                </a:solidFill>
+              </a:rPr>
+              <a:t>اخلاق، میوهٔ ایمان</a:t>
+            </a:r>
+            <a:endParaRPr lang="fa-IR" sz="2200" dirty="0"/>
+          </a:p>
+        </p:txBody>
+      </p:sp>
+      <p:sp>
+        <p:nvSpPr>
+          <p:cNvPr id="8" name="Text 4"/>
+          <p:cNvSpPr txBox="1"/>
+          <p:nvPr/>
+        </p:nvSpPr>
+        <p:spPr>
+          <a:xfrm>
+            <a:off x="5394960" y="1965960"/>
+            <a:ext cx="5105095" cy="914400"/>
+          </a:xfrm>
+          <a:prstGeom prst="rect">
+            <a:avLst/>
+          </a:prstGeom>
+          <a:noFill/>
+          <a:ln/>
+        </p:spPr>
+        <p:txBody>
+          <a:bodyPr wrap="square" lIns="0" tIns="0" rIns="0" bIns="0" rtlCol="0" anchor="t"/>
+          <a:lstStyle/>
+          <a:p>
+            <a:pPr rtl="1" algn="r" indent="0" marL="0">
+              <a:buNone/>
+            </a:pPr>
+            <a:r>
+              <a:rPr lang="fa-IR" altLang="en-US" sz="1700" dirty="0">
+                <a:solidFill>
+                  <a:schemeClr val="tx1"/>
+                </a:solidFill>
+              </a:rPr>
+              <a:t>در اخلاق اسلامی، رفتار نیک از ریشهٔ ایمان و توحید می‌روید؛ فضایل ایمانی سرچشمهٔ فضیلت‌های دیگرند.</a:t>
+            </a:r>
+            <a:endParaRPr lang="fa-IR" sz="1700" dirty="0"/>
+          </a:p>
+        </p:txBody>
+      </p:sp>
+      <p:sp>
+        <p:nvSpPr>
+          <p:cNvPr id="9" name="Shape 5"/>
           <p:cNvSpPr/>
           <p:nvPr/>
         </p:nvSpPr>
         <p:spPr>
           <a:xfrm>
-            <a:off x="10774375" y="1645920"/>
+            <a:off x="10774375" y="3246120"/>
             <a:ext cx="868680" cy="868680"/>
           </a:xfrm>
           <a:prstGeom prst="ellipse">
@@ -14410,21 +14326,21 @@
       </p:sp>
       <p:pic>
         <p:nvPicPr>
-          <p:cNvPr id="8" name="icon FaQuran" descr="preencoded.png">    </p:cNvPr>
+          <p:cNvPr id="10" name="icon FaHandHoldingHeart" descr="preencoded.png">    </p:cNvPr>
           <p:cNvPicPr>
             <a:picLocks noChangeAspect="1"/>
           </p:cNvPicPr>
           <p:nvPr/>
         </p:nvPicPr>
         <p:blipFill>
-          <a:blip r:embed="rId2"/>
+          <a:blip r:embed="rId3"/>
           <a:stretch>
             <a:fillRect/>
           </a:stretch>
         </p:blipFill>
         <p:spPr>
           <a:xfrm>
-            <a:off x="11008919" y="1880464"/>
+            <a:off x="11008919" y="3480664"/>
             <a:ext cx="399593" cy="399593"/>
           </a:xfrm>
           <a:prstGeom prst="rect">
@@ -14434,13 +14350,13 @@
       </p:pic>
       <p:sp>
         <p:nvSpPr>
-          <p:cNvPr id="9" name="Text 5"/>
-          <p:cNvSpPr txBox="1"/>
-          <p:nvPr/>
-        </p:nvSpPr>
-        <p:spPr>
-          <a:xfrm>
-            <a:off x="5394960" y="1463040"/>
+          <p:cNvPr id="11" name="Text 6"/>
+          <p:cNvSpPr txBox="1"/>
+          <p:nvPr/>
+        </p:nvSpPr>
+        <p:spPr>
+          <a:xfrm>
+            <a:off x="5394960" y="3063240"/>
             <a:ext cx="5105095" cy="457200"/>
           </a:xfrm>
           <a:prstGeom prst="rect">
@@ -14462,7 +14378,7 @@
                   <a:schemeClr val="tx2"/>
                 </a:solidFill>
               </a:rPr>
-              <a:t>اخلاق، میوهٔ ایمان</a:t>
+              <a:t>شکر؛ نگاه به گذشته و حال</a:t>
             </a:r>
             <a:endParaRPr lang="fa-IR" sz="2200" dirty="0"/>
           </a:p>
@@ -14470,13 +14386,13 @@
       </p:sp>
       <p:sp>
         <p:nvSpPr>
-          <p:cNvPr id="10" name="Text 6"/>
-          <p:cNvSpPr txBox="1"/>
-          <p:nvPr/>
-        </p:nvSpPr>
-        <p:spPr>
-          <a:xfrm>
-            <a:off x="5394960" y="1965960"/>
+          <p:cNvPr id="12" name="Text 7"/>
+          <p:cNvSpPr txBox="1"/>
+          <p:nvPr/>
+        </p:nvSpPr>
+        <p:spPr>
+          <a:xfrm>
+            <a:off x="5394960" y="3566160"/>
             <a:ext cx="5105095" cy="914400"/>
           </a:xfrm>
           <a:prstGeom prst="rect">
@@ -14498,7 +14414,7 @@
                   <a:schemeClr val="tx1"/>
                 </a:solidFill>
               </a:rPr>
-              <a:t>در اخلاق اسلامی، رفتار نیک از ریشهٔ ایمان و توحید می‌روید؛ فضایل ایمانی سرچشمهٔ فضیلت‌های دیگرند.</a:t>
+              <a:t>شناخت نعمت‌های خدا و سپاس از او، دل را از ناسپاسی و حسرت پاک می‌کند.</a:t>
             </a:r>
             <a:endParaRPr lang="fa-IR" sz="1700" dirty="0"/>
           </a:p>
@@ -14506,13 +14422,13 @@
       </p:sp>
       <p:sp>
         <p:nvSpPr>
-          <p:cNvPr id="11" name="Shape 7"/>
+          <p:cNvPr id="13" name="Shape 8"/>
           <p:cNvSpPr/>
           <p:nvPr/>
         </p:nvSpPr>
         <p:spPr>
           <a:xfrm>
-            <a:off x="10774375" y="3246120"/>
+            <a:off x="10774375" y="4846320"/>
             <a:ext cx="868680" cy="868680"/>
           </a:xfrm>
           <a:prstGeom prst="ellipse">
@@ -14531,128 +14447,7 @@
       </p:sp>
       <p:pic>
         <p:nvPicPr>
-          <p:cNvPr id="12" name="icon FaHandHoldingHeart" descr="preencoded.png">    </p:cNvPr>
-          <p:cNvPicPr>
-            <a:picLocks noChangeAspect="1"/>
-          </p:cNvPicPr>
-          <p:nvPr/>
-        </p:nvPicPr>
-        <p:blipFill>
-          <a:blip r:embed="rId3"/>
-          <a:stretch>
-            <a:fillRect/>
-          </a:stretch>
-        </p:blipFill>
-        <p:spPr>
-          <a:xfrm>
-            <a:off x="11008919" y="3480664"/>
-            <a:ext cx="399593" cy="399593"/>
-          </a:xfrm>
-          <a:prstGeom prst="rect">
-            <a:avLst/>
-          </a:prstGeom>
-        </p:spPr>
-      </p:pic>
-      <p:sp>
-        <p:nvSpPr>
-          <p:cNvPr id="13" name="Text 8"/>
-          <p:cNvSpPr txBox="1"/>
-          <p:nvPr/>
-        </p:nvSpPr>
-        <p:spPr>
-          <a:xfrm>
-            <a:off x="5394960" y="3063240"/>
-            <a:ext cx="5105095" cy="457200"/>
-          </a:xfrm>
-          <a:prstGeom prst="rect">
-            <a:avLst/>
-          </a:prstGeom>
-          <a:noFill/>
-          <a:ln/>
-        </p:spPr>
-        <p:txBody>
-          <a:bodyPr wrap="square" lIns="0" tIns="0" rIns="0" bIns="0" rtlCol="0" anchor="t"/>
-          <a:lstStyle/>
-          <a:p>
-            <a:pPr rtl="1" algn="r" indent="0" marL="0">
-              <a:buNone/>
-            </a:pPr>
-            <a:r>
-              <a:rPr lang="fa-IR" altLang="en-US" sz="2200" b="1" dirty="0">
-                <a:solidFill>
-                  <a:schemeClr val="tx2"/>
-                </a:solidFill>
-              </a:rPr>
-              <a:t>شکر؛ نگاه به گذشته و حال</a:t>
-            </a:r>
-            <a:endParaRPr lang="fa-IR" sz="2200" dirty="0"/>
-          </a:p>
-        </p:txBody>
-      </p:sp>
-      <p:sp>
-        <p:nvSpPr>
-          <p:cNvPr id="14" name="Text 9"/>
-          <p:cNvSpPr txBox="1"/>
-          <p:nvPr/>
-        </p:nvSpPr>
-        <p:spPr>
-          <a:xfrm>
-            <a:off x="5394960" y="3566160"/>
-            <a:ext cx="5105095" cy="914400"/>
-          </a:xfrm>
-          <a:prstGeom prst="rect">
-            <a:avLst/>
-          </a:prstGeom>
-          <a:noFill/>
-          <a:ln/>
-        </p:spPr>
-        <p:txBody>
-          <a:bodyPr wrap="square" lIns="0" tIns="0" rIns="0" bIns="0" rtlCol="0" anchor="t"/>
-          <a:lstStyle/>
-          <a:p>
-            <a:pPr rtl="1" algn="r" indent="0" marL="0">
-              <a:buNone/>
-            </a:pPr>
-            <a:r>
-              <a:rPr lang="fa-IR" altLang="en-US" sz="1700" dirty="0">
-                <a:solidFill>
-                  <a:schemeClr val="tx1"/>
-                </a:solidFill>
-              </a:rPr>
-              <a:t>شناخت نعمت‌های خدا و سپاس از او، دل را از ناسپاسی و حسرت پاک می‌کند.</a:t>
-            </a:r>
-            <a:endParaRPr lang="fa-IR" sz="1700" dirty="0"/>
-          </a:p>
-        </p:txBody>
-      </p:sp>
-      <p:sp>
-        <p:nvSpPr>
-          <p:cNvPr id="15" name="Shape 10"/>
-          <p:cNvSpPr/>
-          <p:nvPr/>
-        </p:nvSpPr>
-        <p:spPr>
-          <a:xfrm>
-            <a:off x="10774375" y="4846320"/>
-            <a:ext cx="868680" cy="868680"/>
-          </a:xfrm>
-          <a:prstGeom prst="ellipse">
-            <a:avLst/>
-          </a:prstGeom>
-          <a:solidFill>
-            <a:srgbClr val="0B5048"/>
-          </a:solidFill>
-          <a:ln w="12700">
-            <a:solidFill>
-              <a:srgbClr val="0B5048"/>
-            </a:solidFill>
-            <a:prstDash val="solid"/>
-          </a:ln>
-        </p:spPr>
-      </p:sp>
-      <p:pic>
-        <p:nvPicPr>
-          <p:cNvPr id="16" name="icon FaShieldAlt" descr="preencoded.png">    </p:cNvPr>
+          <p:cNvPr id="14" name="icon FaShieldAlt" descr="preencoded.png">    </p:cNvPr>
           <p:cNvPicPr>
             <a:picLocks noChangeAspect="1"/>
           </p:cNvPicPr>
@@ -14676,7 +14471,7 @@
       </p:pic>
       <p:sp>
         <p:nvSpPr>
-          <p:cNvPr id="17" name="Text 11"/>
+          <p:cNvPr id="15" name="Text 9"/>
           <p:cNvSpPr txBox="1"/>
           <p:nvPr/>
         </p:nvSpPr>
@@ -14712,7 +14507,7 @@
       </p:sp>
       <p:sp>
         <p:nvSpPr>
-          <p:cNvPr id="18" name="Text 12"/>
+          <p:cNvPr id="16" name="Text 10"/>
           <p:cNvSpPr txBox="1"/>
           <p:nvPr/>
         </p:nvSpPr>
@@ -14824,8 +14619,30 @@
         </p:nvSpPr>
         <p:spPr>
           <a:xfrm>
-            <a:off x="0" y="0"/>
-            <a:ext cx="4937760" cy="6858000"/>
+            <a:off x="694944" y="1517904"/>
+            <a:ext cx="4389120" cy="4572000"/>
+          </a:xfrm>
+          <a:prstGeom prst="rect">
+            <a:avLst/>
+          </a:prstGeom>
+          <a:ln w="19050">
+            <a:solidFill>
+              <a:schemeClr val="accent1"/>
+            </a:solidFill>
+            <a:prstDash val="solid"/>
+          </a:ln>
+        </p:spPr>
+      </p:sp>
+      <p:sp>
+        <p:nvSpPr>
+          <p:cNvPr id="3" name="Shape 1"/>
+          <p:cNvSpPr/>
+          <p:nvPr/>
+        </p:nvSpPr>
+        <p:spPr>
+          <a:xfrm>
+            <a:off x="548640" y="1371600"/>
+            <a:ext cx="4389120" cy="4572000"/>
           </a:xfrm>
           <a:prstGeom prst="rect">
             <a:avLst/>
@@ -14843,14 +14660,14 @@
       </p:sp>
       <p:sp>
         <p:nvSpPr>
-          <p:cNvPr id="3" name="Shape 1"/>
+          <p:cNvPr id="4" name="Shape 2"/>
           <p:cNvSpPr/>
           <p:nvPr/>
         </p:nvSpPr>
         <p:spPr>
           <a:xfrm>
-            <a:off x="790042" y="1750162"/>
-            <a:ext cx="3357677" cy="3357677"/>
+            <a:off x="1250899" y="2165299"/>
+            <a:ext cx="2984602" cy="2984602"/>
           </a:xfrm>
           <a:prstGeom prst="ellipse">
             <a:avLst/>
@@ -14870,7 +14687,7 @@
       </p:sp>
       <p:pic>
         <p:nvPicPr>
-          <p:cNvPr id="4" name="icon FaHandsHelping" descr="preencoded.png">    </p:cNvPr>
+          <p:cNvPr id="5" name="icon FaHandsHelping" descr="preencoded.png">    </p:cNvPr>
           <p:cNvPicPr>
             <a:picLocks noChangeAspect="1"/>
           </p:cNvPicPr>
@@ -14884,8 +14701,8 @@
         </p:blipFill>
         <p:spPr>
           <a:xfrm>
-            <a:off x="1678838" y="2638958"/>
-            <a:ext cx="1580083" cy="1580083"/>
+            <a:off x="2040941" y="2955341"/>
+            <a:ext cx="1404518" cy="1404518"/>
           </a:xfrm>
           <a:prstGeom prst="rect">
             <a:avLst/>
@@ -14894,7 +14711,7 @@
       </p:pic>
       <p:sp>
         <p:nvSpPr>
-          <p:cNvPr id="5" name="Text 2"/>
+          <p:cNvPr id="6" name="Text 3"/>
           <p:cNvSpPr txBox="1"/>
           <p:nvPr/>
         </p:nvSpPr>
@@ -14930,7 +14747,7 @@
       </p:sp>
       <p:sp>
         <p:nvSpPr>
-          <p:cNvPr id="6" name="Text 3"/>
+          <p:cNvPr id="7" name="Text 4"/>
           <p:cNvSpPr txBox="1"/>
           <p:nvPr/>
         </p:nvSpPr>
@@ -14966,7 +14783,7 @@
       </p:sp>
       <p:sp>
         <p:nvSpPr>
-          <p:cNvPr id="7" name="Text 4"/>
+          <p:cNvPr id="8" name="Text 5"/>
           <p:cNvSpPr txBox="1"/>
           <p:nvPr/>
         </p:nvSpPr>
@@ -15002,7 +14819,7 @@
       </p:sp>
       <p:sp>
         <p:nvSpPr>
-          <p:cNvPr id="8" name="Text 5"/>
+          <p:cNvPr id="9" name="Text 6"/>
           <p:cNvSpPr txBox="1"/>
           <p:nvPr/>
         </p:nvSpPr>
@@ -15041,7 +14858,7 @@
       </p:sp>
       <p:sp>
         <p:nvSpPr>
-          <p:cNvPr id="9" name="Text 6"/>
+          <p:cNvPr id="10" name="Text 7"/>
           <p:cNvSpPr txBox="1"/>
           <p:nvPr/>
         </p:nvSpPr>
@@ -15160,12 +14977,20 @@
           </a:ln>
         </p:spPr>
       </p:sp>
-      <p:sp>
-        <p:nvSpPr>
-          <p:cNvPr id="4" name="Shape 2"/>
-          <p:cNvSpPr/>
-          <p:nvPr/>
-        </p:nvSpPr>
+      <p:pic>
+        <p:nvPicPr>
+          <p:cNvPr id="4" name="Image 0" descr="shokr_def">    </p:cNvPr>
+          <p:cNvPicPr>
+            <a:picLocks noChangeAspect="1"/>
+          </p:cNvPicPr>
+          <p:nvPr/>
+        </p:nvPicPr>
+        <p:blipFill>
+          <a:blip r:embed="rId1"/>
+          <a:stretch>
+            <a:fillRect/>
+          </a:stretch>
+        </p:blipFill>
         <p:spPr>
           <a:xfrm>
             <a:off x="548640" y="1463040"/>
@@ -15173,6 +14998,123 @@
           </a:xfrm>
           <a:prstGeom prst="rect">
             <a:avLst/>
+          </a:prstGeom>
+        </p:spPr>
+      </p:pic>
+      <p:sp>
+        <p:nvSpPr>
+          <p:cNvPr id="5" name="Shape 2"/>
+          <p:cNvSpPr/>
+          <p:nvPr/>
+        </p:nvSpPr>
+        <p:spPr>
+          <a:xfrm>
+            <a:off x="5120640" y="1463040"/>
+            <a:ext cx="6522415" cy="2011680"/>
+          </a:xfrm>
+          <a:prstGeom prst="roundRect">
+            <a:avLst>
+              <a:gd name="adj" fmla="val 6364"/>
+            </a:avLst>
+          </a:prstGeom>
+          <a:solidFill>
+            <a:srgbClr val="EAF2EF"/>
+          </a:solidFill>
+          <a:ln w="12700">
+            <a:solidFill>
+              <a:srgbClr val="EAF2EF"/>
+            </a:solidFill>
+            <a:prstDash val="solid"/>
+          </a:ln>
+        </p:spPr>
+      </p:sp>
+      <p:sp>
+        <p:nvSpPr>
+          <p:cNvPr id="6" name="Text 3"/>
+          <p:cNvSpPr txBox="1"/>
+          <p:nvPr/>
+        </p:nvSpPr>
+        <p:spPr>
+          <a:xfrm>
+            <a:off x="5440680" y="1691640"/>
+            <a:ext cx="5882335" cy="411480"/>
+          </a:xfrm>
+          <a:prstGeom prst="rect">
+            <a:avLst/>
+          </a:prstGeom>
+          <a:noFill/>
+          <a:ln/>
+        </p:spPr>
+        <p:txBody>
+          <a:bodyPr wrap="square" lIns="0" tIns="0" rIns="0" bIns="0" rtlCol="0" anchor="t"/>
+          <a:lstStyle/>
+          <a:p>
+            <a:pPr rtl="1" algn="r" indent="0" marL="0">
+              <a:buNone/>
+            </a:pPr>
+            <a:r>
+              <a:rPr lang="fa-IR" altLang="en-US" sz="2000" b="1" dirty="0">
+                <a:solidFill>
+                  <a:schemeClr val="accent2"/>
+                </a:solidFill>
+              </a:rPr>
+              <a:t>در لغت</a:t>
+            </a:r>
+            <a:endParaRPr lang="fa-IR" sz="2000" dirty="0"/>
+          </a:p>
+        </p:txBody>
+      </p:sp>
+      <p:sp>
+        <p:nvSpPr>
+          <p:cNvPr id="7" name="Text 4"/>
+          <p:cNvSpPr txBox="1"/>
+          <p:nvPr/>
+        </p:nvSpPr>
+        <p:spPr>
+          <a:xfrm>
+            <a:off x="5440680" y="2194560"/>
+            <a:ext cx="5882335" cy="1097280"/>
+          </a:xfrm>
+          <a:prstGeom prst="rect">
+            <a:avLst/>
+          </a:prstGeom>
+          <a:noFill/>
+          <a:ln/>
+        </p:spPr>
+        <p:txBody>
+          <a:bodyPr wrap="square" lIns="0" tIns="0" rIns="0" bIns="0" rtlCol="0" anchor="t"/>
+          <a:lstStyle/>
+          <a:p>
+            <a:pPr rtl="1" algn="r" indent="0" marL="0">
+              <a:buNone/>
+            </a:pPr>
+            <a:r>
+              <a:rPr lang="fa-IR" altLang="en-US" sz="2000" dirty="0">
+                <a:solidFill>
+                  <a:schemeClr val="tx1"/>
+                </a:solidFill>
+              </a:rPr>
+              <a:t>شکر یعنی سپاس‌گزاری و ستایش در برابر نعمت؛ ضد آن «کفر» و «کفران» است.</a:t>
+            </a:r>
+            <a:endParaRPr lang="fa-IR" sz="2000" dirty="0"/>
+          </a:p>
+        </p:txBody>
+      </p:sp>
+      <p:sp>
+        <p:nvSpPr>
+          <p:cNvPr id="8" name="Shape 5"/>
+          <p:cNvSpPr/>
+          <p:nvPr/>
+        </p:nvSpPr>
+        <p:spPr>
+          <a:xfrm>
+            <a:off x="5120640" y="3657600"/>
+            <a:ext cx="6522415" cy="2377440"/>
+          </a:xfrm>
+          <a:prstGeom prst="roundRect">
+            <a:avLst>
+              <a:gd name="adj" fmla="val 5385"/>
+            </a:avLst>
           </a:prstGeom>
           <a:solidFill>
             <a:srgbClr val="0B5048"/>
@@ -15187,184 +15129,7 @@
       </p:sp>
       <p:sp>
         <p:nvSpPr>
-          <p:cNvPr id="5" name="Shape 3"/>
-          <p:cNvSpPr/>
-          <p:nvPr/>
-        </p:nvSpPr>
-        <p:spPr>
-          <a:xfrm>
-            <a:off x="1192378" y="2381098"/>
-            <a:ext cx="2735885" cy="2735885"/>
-          </a:xfrm>
-          <a:prstGeom prst="ellipse">
-            <a:avLst/>
-          </a:prstGeom>
-          <a:solidFill>
-            <a:srgbClr val="8CC1B2">
-              <a:alpha val="18000"/>
-            </a:srgbClr>
-          </a:solidFill>
-          <a:ln w="12700">
-            <a:solidFill>
-              <a:srgbClr val="8CC1B2"/>
-            </a:solidFill>
-            <a:prstDash val="solid"/>
-          </a:ln>
-        </p:spPr>
-      </p:sp>
-      <p:pic>
-        <p:nvPicPr>
-          <p:cNvPr id="6" name="icon FaSeedling" descr="preencoded.png">    </p:cNvPr>
-          <p:cNvPicPr>
-            <a:picLocks noChangeAspect="1"/>
-          </p:cNvPicPr>
-          <p:nvPr/>
-        </p:nvPicPr>
-        <p:blipFill>
-          <a:blip r:embed="rId1"/>
-          <a:stretch>
-            <a:fillRect/>
-          </a:stretch>
-        </p:blipFill>
-        <p:spPr>
-          <a:xfrm>
-            <a:off x="1916582" y="3105302"/>
-            <a:ext cx="1287475" cy="1287475"/>
-          </a:xfrm>
-          <a:prstGeom prst="rect">
-            <a:avLst/>
-          </a:prstGeom>
-        </p:spPr>
-      </p:pic>
-      <p:sp>
-        <p:nvSpPr>
-          <p:cNvPr id="7" name="Shape 4"/>
-          <p:cNvSpPr/>
-          <p:nvPr/>
-        </p:nvSpPr>
-        <p:spPr>
-          <a:xfrm>
-            <a:off x="5120640" y="1463040"/>
-            <a:ext cx="6522415" cy="2011680"/>
-          </a:xfrm>
-          <a:prstGeom prst="roundRect">
-            <a:avLst>
-              <a:gd name="adj" fmla="val 6364"/>
-            </a:avLst>
-          </a:prstGeom>
-          <a:solidFill>
-            <a:srgbClr val="EAF2EF"/>
-          </a:solidFill>
-          <a:ln w="12700">
-            <a:solidFill>
-              <a:srgbClr val="EAF2EF"/>
-            </a:solidFill>
-            <a:prstDash val="solid"/>
-          </a:ln>
-        </p:spPr>
-      </p:sp>
-      <p:sp>
-        <p:nvSpPr>
-          <p:cNvPr id="8" name="Text 5"/>
-          <p:cNvSpPr txBox="1"/>
-          <p:nvPr/>
-        </p:nvSpPr>
-        <p:spPr>
-          <a:xfrm>
-            <a:off x="5440680" y="1691640"/>
-            <a:ext cx="5882335" cy="411480"/>
-          </a:xfrm>
-          <a:prstGeom prst="rect">
-            <a:avLst/>
-          </a:prstGeom>
-          <a:noFill/>
-          <a:ln/>
-        </p:spPr>
-        <p:txBody>
-          <a:bodyPr wrap="square" lIns="0" tIns="0" rIns="0" bIns="0" rtlCol="0" anchor="t"/>
-          <a:lstStyle/>
-          <a:p>
-            <a:pPr rtl="1" algn="r" indent="0" marL="0">
-              <a:buNone/>
-            </a:pPr>
-            <a:r>
-              <a:rPr lang="fa-IR" altLang="en-US" sz="2000" b="1" dirty="0">
-                <a:solidFill>
-                  <a:schemeClr val="accent2"/>
-                </a:solidFill>
-              </a:rPr>
-              <a:t>در لغت</a:t>
-            </a:r>
-            <a:endParaRPr lang="fa-IR" sz="2000" dirty="0"/>
-          </a:p>
-        </p:txBody>
-      </p:sp>
-      <p:sp>
-        <p:nvSpPr>
           <p:cNvPr id="9" name="Text 6"/>
-          <p:cNvSpPr txBox="1"/>
-          <p:nvPr/>
-        </p:nvSpPr>
-        <p:spPr>
-          <a:xfrm>
-            <a:off x="5440680" y="2194560"/>
-            <a:ext cx="5882335" cy="1097280"/>
-          </a:xfrm>
-          <a:prstGeom prst="rect">
-            <a:avLst/>
-          </a:prstGeom>
-          <a:noFill/>
-          <a:ln/>
-        </p:spPr>
-        <p:txBody>
-          <a:bodyPr wrap="square" lIns="0" tIns="0" rIns="0" bIns="0" rtlCol="0" anchor="t"/>
-          <a:lstStyle/>
-          <a:p>
-            <a:pPr rtl="1" algn="r" indent="0" marL="0">
-              <a:buNone/>
-            </a:pPr>
-            <a:r>
-              <a:rPr lang="fa-IR" altLang="en-US" sz="2000" dirty="0">
-                <a:solidFill>
-                  <a:schemeClr val="tx1"/>
-                </a:solidFill>
-              </a:rPr>
-              <a:t>شکر یعنی سپاس‌گزاری و ستایش در برابر نعمت؛ ضد آن «کفر» و «کفران» است.</a:t>
-            </a:r>
-            <a:endParaRPr lang="fa-IR" sz="2000" dirty="0"/>
-          </a:p>
-        </p:txBody>
-      </p:sp>
-      <p:sp>
-        <p:nvSpPr>
-          <p:cNvPr id="10" name="Shape 7"/>
-          <p:cNvSpPr/>
-          <p:nvPr/>
-        </p:nvSpPr>
-        <p:spPr>
-          <a:xfrm>
-            <a:off x="5120640" y="3657600"/>
-            <a:ext cx="6522415" cy="2377440"/>
-          </a:xfrm>
-          <a:prstGeom prst="roundRect">
-            <a:avLst>
-              <a:gd name="adj" fmla="val 5385"/>
-            </a:avLst>
-          </a:prstGeom>
-          <a:solidFill>
-            <a:srgbClr val="0B5048"/>
-          </a:solidFill>
-          <a:ln w="12700">
-            <a:solidFill>
-              <a:srgbClr val="0B5048"/>
-            </a:solidFill>
-            <a:prstDash val="solid"/>
-          </a:ln>
-        </p:spPr>
-      </p:sp>
-      <p:sp>
-        <p:nvSpPr>
-          <p:cNvPr id="11" name="Text 8"/>
           <p:cNvSpPr txBox="1"/>
           <p:nvPr/>
         </p:nvSpPr>
@@ -15400,7 +15165,7 @@
       </p:sp>
       <p:sp>
         <p:nvSpPr>
-          <p:cNvPr id="12" name="Text 9"/>
+          <p:cNvPr id="10" name="Text 7"/>
           <p:cNvSpPr txBox="1"/>
           <p:nvPr/>
         </p:nvSpPr>
@@ -15512,11 +15277,209 @@
         </p:nvSpPr>
         <p:spPr>
           <a:xfrm>
-            <a:off x="0" y="0"/>
-            <a:ext cx="3840480" cy="6858000"/>
-          </a:xfrm>
-          <a:prstGeom prst="rect">
-            <a:avLst/>
+            <a:off x="694944" y="1517904"/>
+            <a:ext cx="3657600" cy="4572000"/>
+          </a:xfrm>
+          <a:prstGeom prst="rect">
+            <a:avLst/>
+          </a:prstGeom>
+          <a:ln w="19050">
+            <a:solidFill>
+              <a:schemeClr val="accent1"/>
+            </a:solidFill>
+            <a:prstDash val="solid"/>
+          </a:ln>
+        </p:spPr>
+      </p:sp>
+      <p:pic>
+        <p:nvPicPr>
+          <p:cNvPr id="3" name="Image 0" descr="shokr_verse">    </p:cNvPr>
+          <p:cNvPicPr>
+            <a:picLocks noChangeAspect="1"/>
+          </p:cNvPicPr>
+          <p:nvPr/>
+        </p:nvPicPr>
+        <p:blipFill>
+          <a:blip r:embed="rId1"/>
+          <a:stretch>
+            <a:fillRect/>
+          </a:stretch>
+        </p:blipFill>
+        <p:spPr>
+          <a:xfrm>
+            <a:off x="548640" y="1371600"/>
+            <a:ext cx="3657600" cy="4572000"/>
+          </a:xfrm>
+          <a:prstGeom prst="rect">
+            <a:avLst/>
+          </a:prstGeom>
+        </p:spPr>
+      </p:pic>
+      <p:sp>
+        <p:nvSpPr>
+          <p:cNvPr id="4" name="Text 1"/>
+          <p:cNvSpPr txBox="1"/>
+          <p:nvPr/>
+        </p:nvSpPr>
+        <p:spPr>
+          <a:xfrm>
+            <a:off x="4480560" y="731520"/>
+            <a:ext cx="7159752" cy="548640"/>
+          </a:xfrm>
+          <a:prstGeom prst="rect">
+            <a:avLst/>
+          </a:prstGeom>
+          <a:noFill/>
+          <a:ln/>
+        </p:spPr>
+        <p:txBody>
+          <a:bodyPr wrap="square" lIns="0" tIns="0" rIns="0" bIns="0" rtlCol="0" anchor="t"/>
+          <a:lstStyle/>
+          <a:p>
+            <a:pPr rtl="1" algn="r" indent="0" marL="0">
+              <a:buNone/>
+            </a:pPr>
+            <a:r>
+              <a:rPr lang="fa-IR" altLang="en-US" sz="2200" b="1" dirty="0">
+                <a:solidFill>
+                  <a:schemeClr val="accent3"/>
+                </a:solidFill>
+              </a:rPr>
+              <a:t>وعدهٔ الهی دربارهٔ شکر</a:t>
+            </a:r>
+            <a:endParaRPr lang="fa-IR" sz="2200" dirty="0"/>
+          </a:p>
+        </p:txBody>
+      </p:sp>
+      <p:sp>
+        <p:nvSpPr>
+          <p:cNvPr id="5" name="Text 2"/>
+          <p:cNvSpPr txBox="1"/>
+          <p:nvPr/>
+        </p:nvSpPr>
+        <p:spPr>
+          <a:xfrm>
+            <a:off x="4480560" y="1554480"/>
+            <a:ext cx="7159752" cy="2103120"/>
+          </a:xfrm>
+          <a:prstGeom prst="rect">
+            <a:avLst/>
+          </a:prstGeom>
+          <a:noFill/>
+          <a:ln/>
+        </p:spPr>
+        <p:txBody>
+          <a:bodyPr wrap="square" lIns="0" tIns="0" rIns="0" bIns="0" rtlCol="0" anchor="ctr"/>
+          <a:lstStyle/>
+          <a:p>
+            <a:pPr rtl="1" algn="r" indent="0" marL="0">
+              <a:lnSpc>
+                <a:spcPct val="120000"/>
+              </a:lnSpc>
+              <a:buNone/>
+            </a:pPr>
+            <a:r>
+              <a:rPr lang="ar-SA" altLang="en-US" sz="3800" dirty="0">
+                <a:solidFill>
+                  <a:schemeClr val="accent1"/>
+                </a:solidFill>
+                <a:latin typeface="Times New Roman" pitchFamily="34" charset="0"/>
+                <a:ea typeface="Times New Roman" pitchFamily="34" charset="-122"/>
+                <a:cs typeface="Times New Roman" pitchFamily="34" charset="-120"/>
+              </a:rPr>
+              <a:t>لَئِن شَكَرْتُمْ لَأَزِيدَنَّكُمْ وَلَئِن كَفَرْتُمْ إِنَّ عَذَابِي لَشَدِيدٌ</a:t>
+            </a:r>
+            <a:endParaRPr lang="ar-SA" sz="3800" dirty="0"/>
+          </a:p>
+        </p:txBody>
+      </p:sp>
+      <p:sp>
+        <p:nvSpPr>
+          <p:cNvPr id="6" name="Text 3"/>
+          <p:cNvSpPr txBox="1"/>
+          <p:nvPr/>
+        </p:nvSpPr>
+        <p:spPr>
+          <a:xfrm>
+            <a:off x="4480560" y="3840480"/>
+            <a:ext cx="7159752" cy="1097280"/>
+          </a:xfrm>
+          <a:prstGeom prst="rect">
+            <a:avLst/>
+          </a:prstGeom>
+          <a:noFill/>
+          <a:ln/>
+        </p:spPr>
+        <p:txBody>
+          <a:bodyPr wrap="square" lIns="0" tIns="0" rIns="0" bIns="0" rtlCol="0" anchor="t"/>
+          <a:lstStyle/>
+          <a:p>
+            <a:pPr rtl="1" algn="r" indent="0" marL="0">
+              <a:buNone/>
+            </a:pPr>
+            <a:r>
+              <a:rPr lang="fa-IR" altLang="en-US" sz="2200" dirty="0">
+                <a:solidFill>
+                  <a:schemeClr val="bg1"/>
+                </a:solidFill>
+              </a:rPr>
+              <a:t>«اگر شکرگزاری کنید، [نعمت] شما را افزون می‌کنم و اگر ناسپاسی کنید، عذاب من سخت است.»</a:t>
+            </a:r>
+            <a:endParaRPr lang="fa-IR" sz="2200" dirty="0"/>
+          </a:p>
+        </p:txBody>
+      </p:sp>
+      <p:sp>
+        <p:nvSpPr>
+          <p:cNvPr id="7" name="Text 4"/>
+          <p:cNvSpPr txBox="1"/>
+          <p:nvPr/>
+        </p:nvSpPr>
+        <p:spPr>
+          <a:xfrm>
+            <a:off x="4480560" y="5029200"/>
+            <a:ext cx="7159752" cy="365760"/>
+          </a:xfrm>
+          <a:prstGeom prst="rect">
+            <a:avLst/>
+          </a:prstGeom>
+          <a:noFill/>
+          <a:ln/>
+        </p:spPr>
+        <p:txBody>
+          <a:bodyPr wrap="square" lIns="0" tIns="0" rIns="0" bIns="0" rtlCol="0" anchor="t"/>
+          <a:lstStyle/>
+          <a:p>
+            <a:pPr rtl="1" algn="r" indent="0" marL="0">
+              <a:buNone/>
+            </a:pPr>
+            <a:r>
+              <a:rPr lang="fa-IR" altLang="en-US" sz="1500" dirty="0">
+                <a:solidFill>
+                  <a:schemeClr val="accent3"/>
+                </a:solidFill>
+              </a:rPr>
+              <a:t>ابراهیم، آیهٔ ۷</a:t>
+            </a:r>
+            <a:endParaRPr lang="fa-IR" sz="1500" dirty="0"/>
+          </a:p>
+        </p:txBody>
+      </p:sp>
+      <p:sp>
+        <p:nvSpPr>
+          <p:cNvPr id="8" name="Shape 5"/>
+          <p:cNvSpPr/>
+          <p:nvPr/>
+        </p:nvSpPr>
+        <p:spPr>
+          <a:xfrm>
+            <a:off x="4480560" y="5532120"/>
+            <a:ext cx="3383280" cy="594360"/>
+          </a:xfrm>
+          <a:prstGeom prst="roundRect">
+            <a:avLst>
+              <a:gd name="adj" fmla="val 21538"/>
+            </a:avLst>
           </a:prstGeom>
           <a:solidFill>
             <a:srgbClr val="0B5048"/>
@@ -15531,215 +15494,50 @@
       </p:sp>
       <p:sp>
         <p:nvSpPr>
-          <p:cNvPr id="3" name="Shape 1"/>
-          <p:cNvSpPr/>
-          <p:nvPr/>
-        </p:nvSpPr>
-        <p:spPr>
-          <a:xfrm>
-            <a:off x="614477" y="2123237"/>
-            <a:ext cx="2611526" cy="2611526"/>
-          </a:xfrm>
-          <a:prstGeom prst="ellipse">
-            <a:avLst/>
-          </a:prstGeom>
-          <a:solidFill>
-            <a:srgbClr val="8CC1B2">
-              <a:alpha val="18000"/>
-            </a:srgbClr>
-          </a:solidFill>
-          <a:ln w="12700">
-            <a:solidFill>
-              <a:srgbClr val="8CC1B2"/>
-            </a:solidFill>
-            <a:prstDash val="solid"/>
-          </a:ln>
-        </p:spPr>
-      </p:sp>
-      <p:pic>
-        <p:nvPicPr>
-          <p:cNvPr id="4" name="icon FaQuran" descr="preencoded.png">    </p:cNvPr>
-          <p:cNvPicPr>
-            <a:picLocks noChangeAspect="1"/>
-          </p:cNvPicPr>
-          <p:nvPr/>
-        </p:nvPicPr>
-        <p:blipFill>
-          <a:blip r:embed="rId1"/>
-          <a:stretch>
-            <a:fillRect/>
-          </a:stretch>
-        </p:blipFill>
-        <p:spPr>
-          <a:xfrm>
-            <a:off x="1305763" y="2814523"/>
-            <a:ext cx="1228954" cy="1228954"/>
-          </a:xfrm>
-          <a:prstGeom prst="rect">
-            <a:avLst/>
-          </a:prstGeom>
-        </p:spPr>
-      </p:pic>
-      <p:sp>
-        <p:nvSpPr>
-          <p:cNvPr id="5" name="Text 2"/>
-          <p:cNvSpPr txBox="1"/>
-          <p:nvPr/>
-        </p:nvSpPr>
-        <p:spPr>
-          <a:xfrm>
-            <a:off x="4480560" y="731520"/>
-            <a:ext cx="7159752" cy="548640"/>
-          </a:xfrm>
-          <a:prstGeom prst="rect">
-            <a:avLst/>
-          </a:prstGeom>
-          <a:noFill/>
-          <a:ln/>
-        </p:spPr>
-        <p:txBody>
-          <a:bodyPr wrap="square" lIns="0" tIns="0" rIns="0" bIns="0" rtlCol="0" anchor="t"/>
-          <a:lstStyle/>
-          <a:p>
-            <a:pPr rtl="1" algn="r" indent="0" marL="0">
-              <a:buNone/>
-            </a:pPr>
-            <a:r>
-              <a:rPr lang="fa-IR" altLang="en-US" sz="2200" b="1" dirty="0">
-                <a:solidFill>
-                  <a:schemeClr val="accent3"/>
-                </a:solidFill>
-              </a:rPr>
-              <a:t>وعدهٔ الهی دربارهٔ شکر</a:t>
-            </a:r>
-            <a:endParaRPr lang="fa-IR" sz="2200" dirty="0"/>
-          </a:p>
-        </p:txBody>
-      </p:sp>
-      <p:sp>
-        <p:nvSpPr>
-          <p:cNvPr id="6" name="Text 3"/>
-          <p:cNvSpPr txBox="1"/>
-          <p:nvPr/>
-        </p:nvSpPr>
-        <p:spPr>
-          <a:xfrm>
-            <a:off x="4480560" y="1554480"/>
-            <a:ext cx="7159752" cy="2103120"/>
-          </a:xfrm>
-          <a:prstGeom prst="rect">
-            <a:avLst/>
-          </a:prstGeom>
-          <a:noFill/>
-          <a:ln/>
-        </p:spPr>
-        <p:txBody>
-          <a:bodyPr wrap="square" lIns="0" tIns="0" rIns="0" bIns="0" rtlCol="0" anchor="ctr"/>
-          <a:lstStyle/>
-          <a:p>
-            <a:pPr rtl="1" algn="r" indent="0" marL="0">
-              <a:lnSpc>
-                <a:spcPct val="120000"/>
-              </a:lnSpc>
-              <a:buNone/>
-            </a:pPr>
-            <a:r>
-              <a:rPr lang="ar-SA" altLang="en-US" sz="3800" dirty="0">
-                <a:solidFill>
-                  <a:schemeClr val="accent1"/>
-                </a:solidFill>
-                <a:latin typeface="Times New Roman" pitchFamily="34" charset="0"/>
-                <a:ea typeface="Times New Roman" pitchFamily="34" charset="-122"/>
-                <a:cs typeface="Times New Roman" pitchFamily="34" charset="-120"/>
-              </a:rPr>
-              <a:t>لَئِن شَكَرْتُمْ لَأَزِيدَنَّكُمْ وَلَئِن كَفَرْتُمْ إِنَّ عَذَابِي لَشَدِيدٌ</a:t>
-            </a:r>
-            <a:endParaRPr lang="ar-SA" sz="3800" dirty="0"/>
-          </a:p>
-        </p:txBody>
-      </p:sp>
-      <p:sp>
-        <p:nvSpPr>
-          <p:cNvPr id="7" name="Text 4"/>
-          <p:cNvSpPr txBox="1"/>
-          <p:nvPr/>
-        </p:nvSpPr>
-        <p:spPr>
-          <a:xfrm>
-            <a:off x="4480560" y="3840480"/>
-            <a:ext cx="7159752" cy="1097280"/>
-          </a:xfrm>
-          <a:prstGeom prst="rect">
-            <a:avLst/>
-          </a:prstGeom>
-          <a:noFill/>
-          <a:ln/>
-        </p:spPr>
-        <p:txBody>
-          <a:bodyPr wrap="square" lIns="0" tIns="0" rIns="0" bIns="0" rtlCol="0" anchor="t"/>
-          <a:lstStyle/>
-          <a:p>
-            <a:pPr rtl="1" algn="r" indent="0" marL="0">
-              <a:buNone/>
-            </a:pPr>
-            <a:r>
-              <a:rPr lang="fa-IR" altLang="en-US" sz="2200" dirty="0">
-                <a:solidFill>
-                  <a:schemeClr val="bg1"/>
-                </a:solidFill>
-              </a:rPr>
-              <a:t>«اگر شکرگزاری کنید، [نعمت] شما را افزون می‌کنم و اگر ناسپاسی کنید، عذاب من سخت است.»</a:t>
-            </a:r>
-            <a:endParaRPr lang="fa-IR" sz="2200" dirty="0"/>
-          </a:p>
-        </p:txBody>
-      </p:sp>
-      <p:sp>
-        <p:nvSpPr>
-          <p:cNvPr id="8" name="Text 5"/>
-          <p:cNvSpPr txBox="1"/>
-          <p:nvPr/>
-        </p:nvSpPr>
-        <p:spPr>
-          <a:xfrm>
-            <a:off x="4480560" y="5029200"/>
-            <a:ext cx="7159752" cy="365760"/>
-          </a:xfrm>
-          <a:prstGeom prst="rect">
-            <a:avLst/>
-          </a:prstGeom>
-          <a:noFill/>
-          <a:ln/>
-        </p:spPr>
-        <p:txBody>
-          <a:bodyPr wrap="square" lIns="0" tIns="0" rIns="0" bIns="0" rtlCol="0" anchor="t"/>
-          <a:lstStyle/>
-          <a:p>
-            <a:pPr rtl="1" algn="r" indent="0" marL="0">
-              <a:buNone/>
-            </a:pPr>
-            <a:r>
-              <a:rPr lang="fa-IR" altLang="en-US" sz="1500" dirty="0">
-                <a:solidFill>
-                  <a:schemeClr val="accent3"/>
-                </a:solidFill>
-              </a:rPr>
-              <a:t>ابراهیم، آیهٔ ۷</a:t>
-            </a:r>
-            <a:endParaRPr lang="fa-IR" sz="1500" dirty="0"/>
-          </a:p>
-        </p:txBody>
-      </p:sp>
-      <p:sp>
-        <p:nvSpPr>
-          <p:cNvPr id="9" name="Shape 6"/>
-          <p:cNvSpPr/>
+          <p:cNvPr id="9" name="Text 6"/>
+          <p:cNvSpPr txBox="1"/>
           <p:nvPr/>
         </p:nvSpPr>
         <p:spPr>
           <a:xfrm>
             <a:off x="4480560" y="5532120"/>
             <a:ext cx="3383280" cy="594360"/>
+          </a:xfrm>
+          <a:prstGeom prst="rect">
+            <a:avLst/>
+          </a:prstGeom>
+          <a:noFill/>
+          <a:ln/>
+        </p:spPr>
+        <p:txBody>
+          <a:bodyPr wrap="square" lIns="0" tIns="0" rIns="0" bIns="0" rtlCol="0" anchor="ctr"/>
+          <a:lstStyle/>
+          <a:p>
+            <a:pPr rtl="1" algn="ctr" indent="0" marL="0">
+              <a:buNone/>
+            </a:pPr>
+            <a:r>
+              <a:rPr lang="fa-IR" altLang="en-US" sz="1700" b="1" dirty="0">
+                <a:solidFill>
+                  <a:schemeClr val="accent1"/>
+                </a:solidFill>
+              </a:rPr>
+              <a:t>شکر ← افزایش نعمت</a:t>
+            </a:r>
+            <a:endParaRPr lang="fa-IR" sz="1700" dirty="0"/>
+          </a:p>
+        </p:txBody>
+      </p:sp>
+      <p:sp>
+        <p:nvSpPr>
+          <p:cNvPr id="10" name="Shape 7"/>
+          <p:cNvSpPr/>
+          <p:nvPr/>
+        </p:nvSpPr>
+        <p:spPr>
+          <a:xfrm>
+            <a:off x="8046720" y="5532120"/>
+            <a:ext cx="3593592" cy="594360"/>
           </a:xfrm>
           <a:prstGeom prst="roundRect">
             <a:avLst>
@@ -15759,70 +15557,7 @@
       </p:sp>
       <p:sp>
         <p:nvSpPr>
-          <p:cNvPr id="10" name="Text 7"/>
-          <p:cNvSpPr txBox="1"/>
-          <p:nvPr/>
-        </p:nvSpPr>
-        <p:spPr>
-          <a:xfrm>
-            <a:off x="4480560" y="5532120"/>
-            <a:ext cx="3383280" cy="594360"/>
-          </a:xfrm>
-          <a:prstGeom prst="rect">
-            <a:avLst/>
-          </a:prstGeom>
-          <a:noFill/>
-          <a:ln/>
-        </p:spPr>
-        <p:txBody>
-          <a:bodyPr wrap="square" lIns="0" tIns="0" rIns="0" bIns="0" rtlCol="0" anchor="ctr"/>
-          <a:lstStyle/>
-          <a:p>
-            <a:pPr rtl="1" algn="ctr" indent="0" marL="0">
-              <a:buNone/>
-            </a:pPr>
-            <a:r>
-              <a:rPr lang="fa-IR" altLang="en-US" sz="1700" b="1" dirty="0">
-                <a:solidFill>
-                  <a:schemeClr val="accent1"/>
-                </a:solidFill>
-              </a:rPr>
-              <a:t>شکر ← افزایش نعمت</a:t>
-            </a:r>
-            <a:endParaRPr lang="fa-IR" sz="1700" dirty="0"/>
-          </a:p>
-        </p:txBody>
-      </p:sp>
-      <p:sp>
-        <p:nvSpPr>
-          <p:cNvPr id="11" name="Shape 8"/>
-          <p:cNvSpPr/>
-          <p:nvPr/>
-        </p:nvSpPr>
-        <p:spPr>
-          <a:xfrm>
-            <a:off x="8046720" y="5532120"/>
-            <a:ext cx="3593592" cy="594360"/>
-          </a:xfrm>
-          <a:prstGeom prst="roundRect">
-            <a:avLst>
-              <a:gd name="adj" fmla="val 21538"/>
-            </a:avLst>
-          </a:prstGeom>
-          <a:solidFill>
-            <a:srgbClr val="0B5048"/>
-          </a:solidFill>
-          <a:ln w="12700">
-            <a:solidFill>
-              <a:srgbClr val="0B5048"/>
-            </a:solidFill>
-            <a:prstDash val="solid"/>
-          </a:ln>
-        </p:spPr>
-      </p:sp>
-      <p:sp>
-        <p:nvSpPr>
-          <p:cNvPr id="12" name="Text 9"/>
+          <p:cNvPr id="11" name="Text 8"/>
           <p:cNvSpPr txBox="1"/>
           <p:nvPr/>
         </p:nvSpPr>

</xml_diff>